<commit_message>
Prepare submission PDFs and enforce artifact readiness checks
</commit_message>
<xml_diff>
--- a/output/presentations/hawkerbridge-round1.pptx
+++ b/output/presentations/hawkerbridge-round1.pptx
@@ -2,15 +2,15 @@
 <file path=ppt/presentation.xml><?xml version="1.0" encoding="utf-8"?>
 <p:presentation xmlns:p="http://schemas.openxmlformats.org/presentationml/2006/main">
   <p:sldMasterIdLst>
-    <p:sldMasterId xmlns:r="http://schemas.openxmlformats.org/officeDocument/2006/relationships" id="2147483648" r:id="R75b73eba690f44b9"/>
+    <p:sldMasterId xmlns:r="http://schemas.openxmlformats.org/officeDocument/2006/relationships" id="2147483648" r:id="R78f15efc309d415e"/>
   </p:sldMasterIdLst>
   <p:notesMasterIdLst>
-    <p:notesMasterId xmlns:r="http://schemas.openxmlformats.org/officeDocument/2006/relationships" r:id="R70341a65b94e403d"/>
+    <p:notesMasterId xmlns:r="http://schemas.openxmlformats.org/officeDocument/2006/relationships" r:id="Rabcd435c2b674905"/>
   </p:notesMasterIdLst>
   <p:sldIdLst>
-    <p:sldId xmlns:r="http://schemas.openxmlformats.org/officeDocument/2006/relationships" id="256" r:id="Raa5b59b1d2aa430e"/>
-    <p:sldId xmlns:r="http://schemas.openxmlformats.org/officeDocument/2006/relationships" id="257" r:id="R83266379b63c48c7"/>
-    <p:sldId xmlns:r="http://schemas.openxmlformats.org/officeDocument/2006/relationships" id="258" r:id="R7e5ccc81465b408b"/>
+    <p:sldId xmlns:r="http://schemas.openxmlformats.org/officeDocument/2006/relationships" id="256" r:id="Ra979dcfc14e3497a"/>
+    <p:sldId xmlns:r="http://schemas.openxmlformats.org/officeDocument/2006/relationships" id="257" r:id="Rdd75f4882a234a3f"/>
+    <p:sldId xmlns:r="http://schemas.openxmlformats.org/officeDocument/2006/relationships" id="258" r:id="R488fff60e9804497"/>
   </p:sldIdLst>
   <p:sldSz cx="12191695" cy="6858000"/>
   <p:notesSz cx="6858000" cy="9144000"/>
@@ -3893,7 +3893,7 @@
           <p:cNvPr id="2" name="Rectangle 1">
             <a:extLst xmlns:a="http://schemas.openxmlformats.org/drawingml/2006/main">
               <a:ext uri="{FF2B5EF4-FFF2-40B4-BE49-F238E27FC236}">
-                <a16:creationId xmlns:a16="http://schemas.microsoft.com/office/drawing/2014/main" id="{A179770E-CC86-4934-A9CA-857960358475}"/>
+                <a16:creationId xmlns:a16="http://schemas.microsoft.com/office/drawing/2014/main" id="{EDFF43DA-92D5-48AE-BD7E-457CF86FE83A}"/>
               </a:ext>
             </a:extLst>
           </p:cNvPr>
@@ -3946,7 +3946,7 @@
           <p:cNvPr id="3" name="TextBox 2">
             <a:extLst xmlns:a="http://schemas.openxmlformats.org/drawingml/2006/main">
               <a:ext uri="{FF2B5EF4-FFF2-40B4-BE49-F238E27FC236}">
-                <a16:creationId xmlns:a16="http://schemas.microsoft.com/office/drawing/2014/main" id="{3EFF35F4-646E-4372-AC4D-7C93107C2F9E}"/>
+                <a16:creationId xmlns:a16="http://schemas.microsoft.com/office/drawing/2014/main" id="{AF5417FB-6FB1-474F-82E1-7996BE5990AA}"/>
               </a:ext>
             </a:extLst>
           </p:cNvPr>
@@ -3996,7 +3996,7 @@
           <p:cNvPr id="4" name="TextBox 3">
             <a:extLst xmlns:a="http://schemas.openxmlformats.org/drawingml/2006/main">
               <a:ext uri="{FF2B5EF4-FFF2-40B4-BE49-F238E27FC236}">
-                <a16:creationId xmlns:a16="http://schemas.microsoft.com/office/drawing/2014/main" id="{9041C18C-B3BC-4118-9363-A65424B06A08}"/>
+                <a16:creationId xmlns:a16="http://schemas.microsoft.com/office/drawing/2014/main" id="{9F18916A-9FC4-4367-AEB8-07987D40AB5A}"/>
               </a:ext>
             </a:extLst>
           </p:cNvPr>
@@ -4046,7 +4046,7 @@
           <p:cNvPr id="5" name="TextBox 4">
             <a:extLst xmlns:a="http://schemas.openxmlformats.org/drawingml/2006/main">
               <a:ext uri="{FF2B5EF4-FFF2-40B4-BE49-F238E27FC236}">
-                <a16:creationId xmlns:a16="http://schemas.microsoft.com/office/drawing/2014/main" id="{39C8FF3E-D9A7-4B4D-A3B8-60C8BF625C17}"/>
+                <a16:creationId xmlns:a16="http://schemas.microsoft.com/office/drawing/2014/main" id="{130560C3-27D6-418C-960D-BD7FEDC7B92E}"/>
               </a:ext>
             </a:extLst>
           </p:cNvPr>
@@ -4297,7 +4297,7 @@
           <p:cNvPr id="6" name="TextBox 5">
             <a:extLst xmlns:a="http://schemas.openxmlformats.org/drawingml/2006/main">
               <a:ext uri="{FF2B5EF4-FFF2-40B4-BE49-F238E27FC236}">
-                <a16:creationId xmlns:a16="http://schemas.microsoft.com/office/drawing/2014/main" id="{A31D80B7-27D8-4ACE-9DA3-E4273D4D7EAC}"/>
+                <a16:creationId xmlns:a16="http://schemas.microsoft.com/office/drawing/2014/main" id="{39871BDB-01AC-4E2F-9AE6-04B4730E4889}"/>
               </a:ext>
             </a:extLst>
           </p:cNvPr>
@@ -4345,7 +4345,7 @@
     </p:spTree>
     <p:extLst>
       <p:ext uri="{BB962C8B-B14F-4D97-AF65-F5344CB8AC3E}">
-        <p14:creationId xmlns:p14="http://schemas.microsoft.com/office/powerpoint/2010/main" val="325409533"/>
+        <p14:creationId xmlns:p14="http://schemas.microsoft.com/office/powerpoint/2010/main" val="1866905862"/>
       </p:ext>
     </p:extLst>
   </p:cSld>
@@ -4369,7 +4369,7 @@
           <p:cNvPr id="2" name="Rectangle 1">
             <a:extLst xmlns:a="http://schemas.openxmlformats.org/drawingml/2006/main">
               <a:ext uri="{FF2B5EF4-FFF2-40B4-BE49-F238E27FC236}">
-                <a16:creationId xmlns:a16="http://schemas.microsoft.com/office/drawing/2014/main" id="{F4E6142E-E250-4A92-94E3-67C90B2062E2}"/>
+                <a16:creationId xmlns:a16="http://schemas.microsoft.com/office/drawing/2014/main" id="{69DC7D3C-06C3-49BD-AD31-F70C6080FFA2}"/>
               </a:ext>
             </a:extLst>
           </p:cNvPr>
@@ -4422,7 +4422,7 @@
           <p:cNvPr id="3" name="TextBox 2">
             <a:extLst xmlns:a="http://schemas.openxmlformats.org/drawingml/2006/main">
               <a:ext uri="{FF2B5EF4-FFF2-40B4-BE49-F238E27FC236}">
-                <a16:creationId xmlns:a16="http://schemas.microsoft.com/office/drawing/2014/main" id="{FC2B4800-29F4-4C60-B6BE-1747E2D0DFB4}"/>
+                <a16:creationId xmlns:a16="http://schemas.microsoft.com/office/drawing/2014/main" id="{9F06C1A1-00AA-4801-A83C-0FF97EBE5F4B}"/>
               </a:ext>
             </a:extLst>
           </p:cNvPr>
@@ -4472,7 +4472,7 @@
           <p:cNvPr id="4" name="TextBox 3">
             <a:extLst xmlns:a="http://schemas.openxmlformats.org/drawingml/2006/main">
               <a:ext uri="{FF2B5EF4-FFF2-40B4-BE49-F238E27FC236}">
-                <a16:creationId xmlns:a16="http://schemas.microsoft.com/office/drawing/2014/main" id="{5BC111C7-96F9-496B-BF8D-A21B7D6A6092}"/>
+                <a16:creationId xmlns:a16="http://schemas.microsoft.com/office/drawing/2014/main" id="{4DDFB0C0-DD98-47F8-9F4C-6D5A3C19F425}"/>
               </a:ext>
             </a:extLst>
           </p:cNvPr>
@@ -4522,7 +4522,7 @@
           <p:cNvPr id="5" name="TextBox 4">
             <a:extLst xmlns:a="http://schemas.openxmlformats.org/drawingml/2006/main">
               <a:ext uri="{FF2B5EF4-FFF2-40B4-BE49-F238E27FC236}">
-                <a16:creationId xmlns:a16="http://schemas.microsoft.com/office/drawing/2014/main" id="{7DD67CCE-F6DD-4313-8BA2-2EDBC83B1185}"/>
+                <a16:creationId xmlns:a16="http://schemas.microsoft.com/office/drawing/2014/main" id="{5D842432-A248-4BE9-9A82-115D7863024E}"/>
               </a:ext>
             </a:extLst>
           </p:cNvPr>
@@ -4729,7 +4729,7 @@
           <p:cNvPr id="6" name="TextBox 5">
             <a:extLst xmlns:a="http://schemas.openxmlformats.org/drawingml/2006/main">
               <a:ext uri="{FF2B5EF4-FFF2-40B4-BE49-F238E27FC236}">
-                <a16:creationId xmlns:a16="http://schemas.microsoft.com/office/drawing/2014/main" id="{910D0D31-782C-4D5A-9C0C-972C7377CC5F}"/>
+                <a16:creationId xmlns:a16="http://schemas.microsoft.com/office/drawing/2014/main" id="{8C36471E-5CC8-438C-80A1-7ED48048FE4E}"/>
               </a:ext>
             </a:extLst>
           </p:cNvPr>
@@ -4777,7 +4777,7 @@
     </p:spTree>
     <p:extLst>
       <p:ext uri="{BB962C8B-B14F-4D97-AF65-F5344CB8AC3E}">
-        <p14:creationId xmlns:p14="http://schemas.microsoft.com/office/powerpoint/2010/main" val="192173218"/>
+        <p14:creationId xmlns:p14="http://schemas.microsoft.com/office/powerpoint/2010/main" val="2100103881"/>
       </p:ext>
     </p:extLst>
   </p:cSld>
@@ -4801,7 +4801,7 @@
           <p:cNvPr id="2" name="Rectangle 1">
             <a:extLst xmlns:a="http://schemas.openxmlformats.org/drawingml/2006/main">
               <a:ext uri="{FF2B5EF4-FFF2-40B4-BE49-F238E27FC236}">
-                <a16:creationId xmlns:a16="http://schemas.microsoft.com/office/drawing/2014/main" id="{E8787E49-447E-4EDB-8079-30977E81B18C}"/>
+                <a16:creationId xmlns:a16="http://schemas.microsoft.com/office/drawing/2014/main" id="{39154F79-63C4-4190-B03E-CE04626CE5CA}"/>
               </a:ext>
             </a:extLst>
           </p:cNvPr>
@@ -4854,7 +4854,7 @@
           <p:cNvPr id="3" name="TextBox 2">
             <a:extLst xmlns:a="http://schemas.openxmlformats.org/drawingml/2006/main">
               <a:ext uri="{FF2B5EF4-FFF2-40B4-BE49-F238E27FC236}">
-                <a16:creationId xmlns:a16="http://schemas.microsoft.com/office/drawing/2014/main" id="{DBFFD79B-1BAD-40A4-A3DC-929F24ECB87C}"/>
+                <a16:creationId xmlns:a16="http://schemas.microsoft.com/office/drawing/2014/main" id="{33C83012-8ADE-457A-BB38-470149193B02}"/>
               </a:ext>
             </a:extLst>
           </p:cNvPr>
@@ -4904,7 +4904,7 @@
           <p:cNvPr id="4" name="TextBox 3">
             <a:extLst xmlns:a="http://schemas.openxmlformats.org/drawingml/2006/main">
               <a:ext uri="{FF2B5EF4-FFF2-40B4-BE49-F238E27FC236}">
-                <a16:creationId xmlns:a16="http://schemas.microsoft.com/office/drawing/2014/main" id="{2FB7FDCB-08A9-43FE-9F28-CE3C314932AD}"/>
+                <a16:creationId xmlns:a16="http://schemas.microsoft.com/office/drawing/2014/main" id="{A9B4E841-B929-4E03-A5B2-ACD2B7E40937}"/>
               </a:ext>
             </a:extLst>
           </p:cNvPr>
@@ -4954,7 +4954,7 @@
           <p:cNvPr id="5" name="TextBox 4">
             <a:extLst xmlns:a="http://schemas.openxmlformats.org/drawingml/2006/main">
               <a:ext uri="{FF2B5EF4-FFF2-40B4-BE49-F238E27FC236}">
-                <a16:creationId xmlns:a16="http://schemas.microsoft.com/office/drawing/2014/main" id="{E5C85147-7B4C-4DA6-AC7C-B05691744E96}"/>
+                <a16:creationId xmlns:a16="http://schemas.microsoft.com/office/drawing/2014/main" id="{3CBD2591-B197-44C3-8ACC-5B30FCEECF44}"/>
               </a:ext>
             </a:extLst>
           </p:cNvPr>
@@ -5107,7 +5107,7 @@
                 <a:ea typeface="Arial"/>
                 <a:cs typeface="Arial"/>
               </a:rPr>
-              <a:t> Fewer coordinator hours per closure and fewer residents reporting lost meal access. Pilot targets: halve planning time and verify every proposed site. A funded pilot and organisation subscription are commercial hypotheses, not sales.</a:t>
+              <a:t> Fewer coordinator hours per closure and fewer residents reporting lost meal access. Pilot targets: reduce planning time by 30% and verify every proposed site. A funded pilot and organisation subscription are commercial hypotheses, not sales.</a:t>
             </a:r>
           </a:p>
           <a:p xmlns:a="http://schemas.openxmlformats.org/drawingml/2006/main">
@@ -5161,7 +5161,7 @@
           <p:cNvPr id="6" name="TextBox 5">
             <a:extLst xmlns:a="http://schemas.openxmlformats.org/drawingml/2006/main">
               <a:ext uri="{FF2B5EF4-FFF2-40B4-BE49-F238E27FC236}">
-                <a16:creationId xmlns:a16="http://schemas.microsoft.com/office/drawing/2014/main" id="{0162A60F-D139-4B37-A3F1-0BAAF28E9F28}"/>
+                <a16:creationId xmlns:a16="http://schemas.microsoft.com/office/drawing/2014/main" id="{D3D41F0D-961C-470A-98E7-6557AAC658C0}"/>
               </a:ext>
             </a:extLst>
           </p:cNvPr>
@@ -5209,7 +5209,7 @@
     </p:spTree>
     <p:extLst>
       <p:ext uri="{BB962C8B-B14F-4D97-AF65-F5344CB8AC3E}">
-        <p14:creationId xmlns:p14="http://schemas.microsoft.com/office/powerpoint/2010/main" val="1804840422"/>
+        <p14:creationId xmlns:p14="http://schemas.microsoft.com/office/powerpoint/2010/main" val="1398157697"/>
       </p:ext>
     </p:extLst>
   </p:cSld>

</xml_diff>